<commit_message>
lesson updates and additions
</commit_message>
<xml_diff>
--- a/presentations/REPL v3.pptx
+++ b/presentations/REPL v3.pptx
@@ -816,7 +816,7 @@
   <p:cSld>
     <p:spTree>
       <p:nvGrpSpPr>
-        <p:cNvPr id="174" name="Shape 174"/>
+        <p:cNvPr id="178" name="Shape 178"/>
         <p:cNvGrpSpPr/>
         <p:nvPr/>
       </p:nvGrpSpPr>
@@ -830,7 +830,7 @@
       </p:grpSpPr>
       <p:sp>
         <p:nvSpPr>
-          <p:cNvPr id="175" name="Google Shape;175;gb8acfec02f_0_14:notes"/>
+          <p:cNvPr id="179" name="Google Shape;179;gb8acfec02f_0_14:notes"/>
           <p:cNvSpPr/>
           <p:nvPr>
             <p:ph idx="2" type="sldImg"/>
@@ -865,7 +865,7 @@
       </p:sp>
       <p:sp>
         <p:nvSpPr>
-          <p:cNvPr id="176" name="Google Shape;176;gb8acfec02f_0_14:notes"/>
+          <p:cNvPr id="180" name="Google Shape;180;gb8acfec02f_0_14:notes"/>
           <p:cNvSpPr txBox="1"/>
           <p:nvPr>
             <p:ph idx="1" type="body"/>
@@ -915,7 +915,7 @@
   <p:cSld>
     <p:spTree>
       <p:nvGrpSpPr>
-        <p:cNvPr id="184" name="Shape 184"/>
+        <p:cNvPr id="188" name="Shape 188"/>
         <p:cNvGrpSpPr/>
         <p:nvPr/>
       </p:nvGrpSpPr>
@@ -929,7 +929,7 @@
       </p:grpSpPr>
       <p:sp>
         <p:nvSpPr>
-          <p:cNvPr id="185" name="Google Shape;185;g20c89bfe95e_0_0:notes"/>
+          <p:cNvPr id="189" name="Google Shape;189;g20c89bfe95e_0_0:notes"/>
           <p:cNvSpPr/>
           <p:nvPr>
             <p:ph idx="2" type="sldImg"/>
@@ -964,7 +964,7 @@
       </p:sp>
       <p:sp>
         <p:nvSpPr>
-          <p:cNvPr id="186" name="Google Shape;186;g20c89bfe95e_0_0:notes"/>
+          <p:cNvPr id="190" name="Google Shape;190;g20c89bfe95e_0_0:notes"/>
           <p:cNvSpPr txBox="1"/>
           <p:nvPr>
             <p:ph idx="1" type="body"/>
@@ -1014,7 +1014,7 @@
   <p:cSld>
     <p:spTree>
       <p:nvGrpSpPr>
-        <p:cNvPr id="197" name="Shape 197"/>
+        <p:cNvPr id="201" name="Shape 201"/>
         <p:cNvGrpSpPr/>
         <p:nvPr/>
       </p:nvGrpSpPr>
@@ -1028,7 +1028,7 @@
       </p:grpSpPr>
       <p:sp>
         <p:nvSpPr>
-          <p:cNvPr id="198" name="Google Shape;198;g3dd07ce15c2_0_12:notes"/>
+          <p:cNvPr id="202" name="Google Shape;202;g3dd07ce15c2_0_12:notes"/>
           <p:cNvSpPr/>
           <p:nvPr>
             <p:ph idx="2" type="sldImg"/>
@@ -1063,7 +1063,7 @@
       </p:sp>
       <p:sp>
         <p:nvSpPr>
-          <p:cNvPr id="199" name="Google Shape;199;g3dd07ce15c2_0_12:notes"/>
+          <p:cNvPr id="203" name="Google Shape;203;g3dd07ce15c2_0_12:notes"/>
           <p:cNvSpPr txBox="1"/>
           <p:nvPr>
             <p:ph idx="1" type="body"/>
@@ -1102,7 +1102,7 @@
       </p:sp>
       <p:sp>
         <p:nvSpPr>
-          <p:cNvPr id="200" name="Google Shape;200;g3dd07ce15c2_0_12:notes"/>
+          <p:cNvPr id="204" name="Google Shape;204;g3dd07ce15c2_0_12:notes"/>
           <p:cNvSpPr txBox="1"/>
           <p:nvPr>
             <p:ph idx="12" type="sldNum"/>
@@ -1157,7 +1157,7 @@
   <p:cSld>
     <p:spTree>
       <p:nvGrpSpPr>
-        <p:cNvPr id="207" name="Shape 207"/>
+        <p:cNvPr id="211" name="Shape 211"/>
         <p:cNvGrpSpPr/>
         <p:nvPr/>
       </p:nvGrpSpPr>
@@ -1171,7 +1171,7 @@
       </p:grpSpPr>
       <p:sp>
         <p:nvSpPr>
-          <p:cNvPr id="208" name="Google Shape;208;g3dd07ce15c2_0_21:notes"/>
+          <p:cNvPr id="212" name="Google Shape;212;g3dd07ce15c2_0_21:notes"/>
           <p:cNvSpPr/>
           <p:nvPr>
             <p:ph idx="2" type="sldImg"/>
@@ -1206,7 +1206,7 @@
       </p:sp>
       <p:sp>
         <p:nvSpPr>
-          <p:cNvPr id="209" name="Google Shape;209;g3dd07ce15c2_0_21:notes"/>
+          <p:cNvPr id="213" name="Google Shape;213;g3dd07ce15c2_0_21:notes"/>
           <p:cNvSpPr txBox="1"/>
           <p:nvPr>
             <p:ph idx="1" type="body"/>
@@ -1245,7 +1245,7 @@
       </p:sp>
       <p:sp>
         <p:nvSpPr>
-          <p:cNvPr id="210" name="Google Shape;210;g3dd07ce15c2_0_21:notes"/>
+          <p:cNvPr id="214" name="Google Shape;214;g3dd07ce15c2_0_21:notes"/>
           <p:cNvSpPr txBox="1"/>
           <p:nvPr>
             <p:ph idx="12" type="sldNum"/>
@@ -1300,7 +1300,7 @@
   <p:cSld>
     <p:spTree>
       <p:nvGrpSpPr>
-        <p:cNvPr id="217" name="Shape 217"/>
+        <p:cNvPr id="221" name="Shape 221"/>
         <p:cNvGrpSpPr/>
         <p:nvPr/>
       </p:nvGrpSpPr>
@@ -1314,7 +1314,7 @@
       </p:grpSpPr>
       <p:sp>
         <p:nvSpPr>
-          <p:cNvPr id="218" name="Google Shape;218;g20c89bfe95e_0_12:notes"/>
+          <p:cNvPr id="222" name="Google Shape;222;g20c89bfe95e_0_12:notes"/>
           <p:cNvSpPr/>
           <p:nvPr>
             <p:ph idx="2" type="sldImg"/>
@@ -1349,7 +1349,7 @@
       </p:sp>
       <p:sp>
         <p:nvSpPr>
-          <p:cNvPr id="219" name="Google Shape;219;g20c89bfe95e_0_12:notes"/>
+          <p:cNvPr id="223" name="Google Shape;223;g20c89bfe95e_0_12:notes"/>
           <p:cNvSpPr txBox="1"/>
           <p:nvPr>
             <p:ph idx="1" type="body"/>
@@ -1399,7 +1399,7 @@
   <p:cSld>
     <p:spTree>
       <p:nvGrpSpPr>
-        <p:cNvPr id="230" name="Shape 230"/>
+        <p:cNvPr id="234" name="Shape 234"/>
         <p:cNvGrpSpPr/>
         <p:nvPr/>
       </p:nvGrpSpPr>
@@ -1413,7 +1413,7 @@
       </p:grpSpPr>
       <p:sp>
         <p:nvSpPr>
-          <p:cNvPr id="231" name="Google Shape;231;g446a604d95_0_5:notes"/>
+          <p:cNvPr id="235" name="Google Shape;235;g446a604d95_0_5:notes"/>
           <p:cNvSpPr/>
           <p:nvPr>
             <p:ph idx="2" type="sldImg"/>
@@ -1448,7 +1448,7 @@
       </p:sp>
       <p:sp>
         <p:nvSpPr>
-          <p:cNvPr id="232" name="Google Shape;232;g446a604d95_0_5:notes"/>
+          <p:cNvPr id="236" name="Google Shape;236;g446a604d95_0_5:notes"/>
           <p:cNvSpPr txBox="1"/>
           <p:nvPr>
             <p:ph idx="1" type="body"/>
@@ -1498,7 +1498,7 @@
   <p:cSld>
     <p:spTree>
       <p:nvGrpSpPr>
-        <p:cNvPr id="245" name="Shape 245"/>
+        <p:cNvPr id="249" name="Shape 249"/>
         <p:cNvGrpSpPr/>
         <p:nvPr/>
       </p:nvGrpSpPr>
@@ -1512,7 +1512,7 @@
       </p:grpSpPr>
       <p:sp>
         <p:nvSpPr>
-          <p:cNvPr id="246" name="Google Shape;246;ga3014a3f69_0_1:notes"/>
+          <p:cNvPr id="250" name="Google Shape;250;ga3014a3f69_0_1:notes"/>
           <p:cNvSpPr/>
           <p:nvPr>
             <p:ph idx="2" type="sldImg"/>
@@ -1547,7 +1547,7 @@
       </p:sp>
       <p:sp>
         <p:nvSpPr>
-          <p:cNvPr id="247" name="Google Shape;247;ga3014a3f69_0_1:notes"/>
+          <p:cNvPr id="251" name="Google Shape;251;ga3014a3f69_0_1:notes"/>
           <p:cNvSpPr txBox="1"/>
           <p:nvPr>
             <p:ph idx="1" type="body"/>
@@ -1597,7 +1597,7 @@
   <p:cSld>
     <p:spTree>
       <p:nvGrpSpPr>
-        <p:cNvPr id="257" name="Shape 257"/>
+        <p:cNvPr id="261" name="Shape 261"/>
         <p:cNvGrpSpPr/>
         <p:nvPr/>
       </p:nvGrpSpPr>
@@ -1611,7 +1611,7 @@
       </p:grpSpPr>
       <p:sp>
         <p:nvSpPr>
-          <p:cNvPr id="258" name="Google Shape;258;g3d3c6ab39dd_0_52:notes"/>
+          <p:cNvPr id="262" name="Google Shape;262;g3d3c6ab39dd_0_52:notes"/>
           <p:cNvSpPr txBox="1"/>
           <p:nvPr>
             <p:ph idx="1" type="body"/>
@@ -1650,7 +1650,7 @@
       </p:sp>
       <p:sp>
         <p:nvSpPr>
-          <p:cNvPr id="259" name="Google Shape;259;g3d3c6ab39dd_0_52:notes"/>
+          <p:cNvPr id="263" name="Google Shape;263;g3d3c6ab39dd_0_52:notes"/>
           <p:cNvSpPr/>
           <p:nvPr>
             <p:ph idx="2" type="sldImg"/>
@@ -1809,7 +1809,7 @@
       </p:grpSpPr>
       <p:sp>
         <p:nvSpPr>
-          <p:cNvPr id="120" name="Google Shape;120;g9cfa74970a_0_0:notes"/>
+          <p:cNvPr id="120" name="Google Shape;120;g3dd07ce15c2_0_0:notes"/>
           <p:cNvSpPr/>
           <p:nvPr>
             <p:ph idx="2" type="sldImg"/>
@@ -1844,7 +1844,7 @@
       </p:sp>
       <p:sp>
         <p:nvSpPr>
-          <p:cNvPr id="121" name="Google Shape;121;g9cfa74970a_0_0:notes"/>
+          <p:cNvPr id="121" name="Google Shape;121;g3dd07ce15c2_0_0:notes"/>
           <p:cNvSpPr txBox="1"/>
           <p:nvPr>
             <p:ph idx="1" type="body"/>
@@ -1926,7 +1926,7 @@
   <p:cSld>
     <p:spTree>
       <p:nvGrpSpPr>
-        <p:cNvPr id="125" name="Shape 125"/>
+        <p:cNvPr id="128" name="Shape 128"/>
         <p:cNvGrpSpPr/>
         <p:nvPr/>
       </p:nvGrpSpPr>
@@ -1940,7 +1940,7 @@
       </p:grpSpPr>
       <p:sp>
         <p:nvSpPr>
-          <p:cNvPr id="126" name="Google Shape;126;g3dd07ce15c2_0_0:notes"/>
+          <p:cNvPr id="129" name="Google Shape;129;g9fa940edee_0_7:notes"/>
           <p:cNvSpPr/>
           <p:nvPr>
             <p:ph idx="2" type="sldImg"/>
@@ -1975,7 +1975,7 @@
       </p:sp>
       <p:sp>
         <p:nvSpPr>
-          <p:cNvPr id="127" name="Google Shape;127;g3dd07ce15c2_0_0:notes"/>
+          <p:cNvPr id="130" name="Google Shape;130;g9fa940edee_0_7:notes"/>
           <p:cNvSpPr txBox="1"/>
           <p:nvPr>
             <p:ph idx="1" type="body"/>
@@ -2057,7 +2057,7 @@
   <p:cSld>
     <p:spTree>
       <p:nvGrpSpPr>
-        <p:cNvPr id="134" name="Shape 134"/>
+        <p:cNvPr id="135" name="Shape 135"/>
         <p:cNvGrpSpPr/>
         <p:nvPr/>
       </p:nvGrpSpPr>
@@ -2071,7 +2071,7 @@
       </p:grpSpPr>
       <p:sp>
         <p:nvSpPr>
-          <p:cNvPr id="135" name="Google Shape;135;g9fa940edee_0_7:notes"/>
+          <p:cNvPr id="136" name="Google Shape;136;g9cfa74970a_0_0:notes"/>
           <p:cNvSpPr/>
           <p:nvPr>
             <p:ph idx="2" type="sldImg"/>
@@ -2106,7 +2106,7 @@
       </p:sp>
       <p:sp>
         <p:nvSpPr>
-          <p:cNvPr id="136" name="Google Shape;136;g9fa940edee_0_7:notes"/>
+          <p:cNvPr id="137" name="Google Shape;137;g9cfa74970a_0_0:notes"/>
           <p:cNvSpPr txBox="1"/>
           <p:nvPr>
             <p:ph idx="1" type="body"/>
@@ -2188,7 +2188,7 @@
   <p:cSld>
     <p:spTree>
       <p:nvGrpSpPr>
-        <p:cNvPr id="141" name="Shape 141"/>
+        <p:cNvPr id="145" name="Shape 145"/>
         <p:cNvGrpSpPr/>
         <p:nvPr/>
       </p:nvGrpSpPr>
@@ -2202,7 +2202,7 @@
       </p:grpSpPr>
       <p:sp>
         <p:nvSpPr>
-          <p:cNvPr id="142" name="Google Shape;142;g7d5853f914ccd074_6:notes"/>
+          <p:cNvPr id="146" name="Google Shape;146;g7d5853f914ccd074_6:notes"/>
           <p:cNvSpPr/>
           <p:nvPr>
             <p:ph idx="2" type="sldImg"/>
@@ -2237,7 +2237,7 @@
       </p:sp>
       <p:sp>
         <p:nvSpPr>
-          <p:cNvPr id="143" name="Google Shape;143;g7d5853f914ccd074_6:notes"/>
+          <p:cNvPr id="147" name="Google Shape;147;g7d5853f914ccd074_6:notes"/>
           <p:cNvSpPr txBox="1"/>
           <p:nvPr>
             <p:ph idx="1" type="body"/>
@@ -2287,7 +2287,7 @@
   <p:cSld>
     <p:spTree>
       <p:nvGrpSpPr>
-        <p:cNvPr id="147" name="Shape 147"/>
+        <p:cNvPr id="151" name="Shape 151"/>
         <p:cNvGrpSpPr/>
         <p:nvPr/>
       </p:nvGrpSpPr>
@@ -2301,7 +2301,7 @@
       </p:grpSpPr>
       <p:sp>
         <p:nvSpPr>
-          <p:cNvPr id="148" name="Google Shape;148;gb30a5969e3_0_15:notes"/>
+          <p:cNvPr id="152" name="Google Shape;152;gb30a5969e3_0_15:notes"/>
           <p:cNvSpPr/>
           <p:nvPr>
             <p:ph idx="2" type="sldImg"/>
@@ -2336,7 +2336,7 @@
       </p:sp>
       <p:sp>
         <p:nvSpPr>
-          <p:cNvPr id="149" name="Google Shape;149;gb30a5969e3_0_15:notes"/>
+          <p:cNvPr id="153" name="Google Shape;153;gb30a5969e3_0_15:notes"/>
           <p:cNvSpPr txBox="1"/>
           <p:nvPr>
             <p:ph idx="1" type="body"/>
@@ -2386,7 +2386,7 @@
   <p:cSld>
     <p:spTree>
       <p:nvGrpSpPr>
-        <p:cNvPr id="153" name="Shape 153"/>
+        <p:cNvPr id="157" name="Shape 157"/>
         <p:cNvGrpSpPr/>
         <p:nvPr/>
       </p:nvGrpSpPr>
@@ -2400,7 +2400,7 @@
       </p:grpSpPr>
       <p:sp>
         <p:nvSpPr>
-          <p:cNvPr id="154" name="Google Shape;154;gb30a5969e3_0_7:notes"/>
+          <p:cNvPr id="158" name="Google Shape;158;gb30a5969e3_0_7:notes"/>
           <p:cNvSpPr/>
           <p:nvPr>
             <p:ph idx="2" type="sldImg"/>
@@ -2435,7 +2435,7 @@
       </p:sp>
       <p:sp>
         <p:nvSpPr>
-          <p:cNvPr id="155" name="Google Shape;155;gb30a5969e3_0_7:notes"/>
+          <p:cNvPr id="159" name="Google Shape;159;gb30a5969e3_0_7:notes"/>
           <p:cNvSpPr txBox="1"/>
           <p:nvPr>
             <p:ph idx="1" type="body"/>
@@ -2485,7 +2485,7 @@
   <p:cSld>
     <p:spTree>
       <p:nvGrpSpPr>
-        <p:cNvPr id="159" name="Shape 159"/>
+        <p:cNvPr id="163" name="Shape 163"/>
         <p:cNvGrpSpPr/>
         <p:nvPr/>
       </p:nvGrpSpPr>
@@ -2499,7 +2499,7 @@
       </p:grpSpPr>
       <p:sp>
         <p:nvSpPr>
-          <p:cNvPr id="160" name="Google Shape;160;g9fa940edee_0_14:notes"/>
+          <p:cNvPr id="164" name="Google Shape;164;g9fa940edee_0_14:notes"/>
           <p:cNvSpPr/>
           <p:nvPr>
             <p:ph idx="2" type="sldImg"/>
@@ -2534,7 +2534,7 @@
       </p:sp>
       <p:sp>
         <p:nvSpPr>
-          <p:cNvPr id="161" name="Google Shape;161;g9fa940edee_0_14:notes"/>
+          <p:cNvPr id="165" name="Google Shape;165;g9fa940edee_0_14:notes"/>
           <p:cNvSpPr txBox="1"/>
           <p:nvPr>
             <p:ph idx="1" type="body"/>
@@ -15002,7 +15002,7 @@
   <p:cSld>
     <p:spTree>
       <p:nvGrpSpPr>
-        <p:cNvPr id="177" name="Shape 177"/>
+        <p:cNvPr id="181" name="Shape 181"/>
         <p:cNvGrpSpPr/>
         <p:nvPr/>
       </p:nvGrpSpPr>
@@ -15016,7 +15016,7 @@
       </p:grpSpPr>
       <p:sp>
         <p:nvSpPr>
-          <p:cNvPr id="178" name="Google Shape;178;p35"/>
+          <p:cNvPr id="182" name="Google Shape;182;p35"/>
           <p:cNvSpPr txBox="1"/>
           <p:nvPr>
             <p:ph type="title"/>
@@ -15056,7 +15056,7 @@
       </p:sp>
       <p:pic>
         <p:nvPicPr>
-          <p:cNvPr id="179" name="Google Shape;179;p35"/>
+          <p:cNvPr id="183" name="Google Shape;183;p35"/>
           <p:cNvPicPr preferRelativeResize="0"/>
           <p:nvPr/>
         </p:nvPicPr>
@@ -15084,7 +15084,7 @@
       </p:pic>
       <p:sp>
         <p:nvSpPr>
-          <p:cNvPr id="180" name="Google Shape;180;p35"/>
+          <p:cNvPr id="184" name="Google Shape;184;p35"/>
           <p:cNvSpPr txBox="1"/>
           <p:nvPr/>
         </p:nvSpPr>
@@ -15142,7 +15142,7 @@
       </p:sp>
       <p:sp>
         <p:nvSpPr>
-          <p:cNvPr id="181" name="Google Shape;181;p35"/>
+          <p:cNvPr id="185" name="Google Shape;185;p35"/>
           <p:cNvSpPr txBox="1"/>
           <p:nvPr/>
         </p:nvSpPr>
@@ -15292,7 +15292,7 @@
       </p:sp>
       <p:sp>
         <p:nvSpPr>
-          <p:cNvPr id="182" name="Google Shape;182;p35"/>
+          <p:cNvPr id="186" name="Google Shape;186;p35"/>
           <p:cNvSpPr txBox="1"/>
           <p:nvPr/>
         </p:nvSpPr>
@@ -15350,7 +15350,7 @@
       </p:sp>
       <p:sp>
         <p:nvSpPr>
-          <p:cNvPr id="183" name="Google Shape;183;p35"/>
+          <p:cNvPr id="187" name="Google Shape;187;p35"/>
           <p:cNvSpPr txBox="1"/>
           <p:nvPr/>
         </p:nvSpPr>
@@ -15419,7 +15419,7 @@
   <p:cSld>
     <p:spTree>
       <p:nvGrpSpPr>
-        <p:cNvPr id="187" name="Shape 187"/>
+        <p:cNvPr id="191" name="Shape 191"/>
         <p:cNvGrpSpPr/>
         <p:nvPr/>
       </p:nvGrpSpPr>
@@ -15433,7 +15433,7 @@
       </p:grpSpPr>
       <p:sp>
         <p:nvSpPr>
-          <p:cNvPr id="188" name="Google Shape;188;p36"/>
+          <p:cNvPr id="192" name="Google Shape;192;p36"/>
           <p:cNvSpPr txBox="1"/>
           <p:nvPr>
             <p:ph type="title"/>
@@ -15473,7 +15473,7 @@
       </p:sp>
       <p:pic>
         <p:nvPicPr>
-          <p:cNvPr id="189" name="Google Shape;189;p36"/>
+          <p:cNvPr id="193" name="Google Shape;193;p36"/>
           <p:cNvPicPr preferRelativeResize="0"/>
           <p:nvPr/>
         </p:nvPicPr>
@@ -15501,7 +15501,7 @@
       </p:pic>
       <p:sp>
         <p:nvSpPr>
-          <p:cNvPr id="190" name="Google Shape;190;p36"/>
+          <p:cNvPr id="194" name="Google Shape;194;p36"/>
           <p:cNvSpPr txBox="1"/>
           <p:nvPr/>
         </p:nvSpPr>
@@ -15559,7 +15559,7 @@
       </p:sp>
       <p:sp>
         <p:nvSpPr>
-          <p:cNvPr id="191" name="Google Shape;191;p36"/>
+          <p:cNvPr id="195" name="Google Shape;195;p36"/>
           <p:cNvSpPr txBox="1"/>
           <p:nvPr/>
         </p:nvSpPr>
@@ -15637,7 +15637,7 @@
       </p:sp>
       <p:sp>
         <p:nvSpPr>
-          <p:cNvPr id="192" name="Google Shape;192;p36"/>
+          <p:cNvPr id="196" name="Google Shape;196;p36"/>
           <p:cNvSpPr txBox="1"/>
           <p:nvPr/>
         </p:nvSpPr>
@@ -15695,7 +15695,7 @@
       </p:sp>
       <p:sp>
         <p:nvSpPr>
-          <p:cNvPr id="193" name="Google Shape;193;p36"/>
+          <p:cNvPr id="197" name="Google Shape;197;p36"/>
           <p:cNvSpPr txBox="1"/>
           <p:nvPr/>
         </p:nvSpPr>
@@ -15753,7 +15753,7 @@
       </p:sp>
       <p:sp>
         <p:nvSpPr>
-          <p:cNvPr id="194" name="Google Shape;194;p36"/>
+          <p:cNvPr id="198" name="Google Shape;198;p36"/>
           <p:cNvSpPr txBox="1"/>
           <p:nvPr/>
         </p:nvSpPr>
@@ -15811,7 +15811,7 @@
       </p:sp>
       <p:sp>
         <p:nvSpPr>
-          <p:cNvPr id="195" name="Google Shape;195;p36"/>
+          <p:cNvPr id="199" name="Google Shape;199;p36"/>
           <p:cNvSpPr txBox="1"/>
           <p:nvPr/>
         </p:nvSpPr>
@@ -15889,7 +15889,7 @@
       </p:sp>
       <p:sp>
         <p:nvSpPr>
-          <p:cNvPr id="196" name="Google Shape;196;p36"/>
+          <p:cNvPr id="200" name="Google Shape;200;p36"/>
           <p:cNvSpPr txBox="1"/>
           <p:nvPr/>
         </p:nvSpPr>
@@ -15985,7 +15985,7 @@
     </p:bg>
     <p:spTree>
       <p:nvGrpSpPr>
-        <p:cNvPr id="201" name="Shape 201"/>
+        <p:cNvPr id="205" name="Shape 205"/>
         <p:cNvGrpSpPr/>
         <p:nvPr/>
       </p:nvGrpSpPr>
@@ -15999,7 +15999,7 @@
       </p:grpSpPr>
       <p:sp>
         <p:nvSpPr>
-          <p:cNvPr id="202" name="Google Shape;202;p37"/>
+          <p:cNvPr id="206" name="Google Shape;206;p37"/>
           <p:cNvSpPr txBox="1"/>
           <p:nvPr>
             <p:ph type="title"/>
@@ -16047,7 +16047,7 @@
       </p:sp>
       <p:sp>
         <p:nvSpPr>
-          <p:cNvPr id="203" name="Google Shape;203;p37"/>
+          <p:cNvPr id="207" name="Google Shape;207;p37"/>
           <p:cNvSpPr txBox="1"/>
           <p:nvPr/>
         </p:nvSpPr>
@@ -16088,7 +16088,7 @@
       </p:sp>
       <p:sp>
         <p:nvSpPr>
-          <p:cNvPr id="204" name="Google Shape;204;p37"/>
+          <p:cNvPr id="208" name="Google Shape;208;p37"/>
           <p:cNvSpPr txBox="1"/>
           <p:nvPr/>
         </p:nvSpPr>
@@ -16138,7 +16138,7 @@
       </p:sp>
       <p:sp>
         <p:nvSpPr>
-          <p:cNvPr id="205" name="Google Shape;205;p37"/>
+          <p:cNvPr id="209" name="Google Shape;209;p37"/>
           <p:cNvSpPr txBox="1"/>
           <p:nvPr/>
         </p:nvSpPr>
@@ -16212,7 +16212,7 @@
       </p:sp>
       <p:sp>
         <p:nvSpPr>
-          <p:cNvPr id="206" name="Google Shape;206;p37"/>
+          <p:cNvPr id="210" name="Google Shape;210;p37"/>
           <p:cNvSpPr txBox="1"/>
           <p:nvPr/>
         </p:nvSpPr>
@@ -16276,7 +16276,7 @@
     </p:bg>
     <p:spTree>
       <p:nvGrpSpPr>
-        <p:cNvPr id="211" name="Shape 211"/>
+        <p:cNvPr id="215" name="Shape 215"/>
         <p:cNvGrpSpPr/>
         <p:nvPr/>
       </p:nvGrpSpPr>
@@ -16290,7 +16290,7 @@
       </p:grpSpPr>
       <p:sp>
         <p:nvSpPr>
-          <p:cNvPr id="212" name="Google Shape;212;p38"/>
+          <p:cNvPr id="216" name="Google Shape;216;p38"/>
           <p:cNvSpPr txBox="1"/>
           <p:nvPr>
             <p:ph type="title"/>
@@ -16338,7 +16338,7 @@
       </p:sp>
       <p:sp>
         <p:nvSpPr>
-          <p:cNvPr id="213" name="Google Shape;213;p38"/>
+          <p:cNvPr id="217" name="Google Shape;217;p38"/>
           <p:cNvSpPr txBox="1"/>
           <p:nvPr/>
         </p:nvSpPr>
@@ -16379,7 +16379,7 @@
       </p:sp>
       <p:sp>
         <p:nvSpPr>
-          <p:cNvPr id="214" name="Google Shape;214;p38"/>
+          <p:cNvPr id="218" name="Google Shape;218;p38"/>
           <p:cNvSpPr txBox="1"/>
           <p:nvPr/>
         </p:nvSpPr>
@@ -16429,7 +16429,7 @@
       </p:sp>
       <p:sp>
         <p:nvSpPr>
-          <p:cNvPr id="215" name="Google Shape;215;p38"/>
+          <p:cNvPr id="219" name="Google Shape;219;p38"/>
           <p:cNvSpPr txBox="1"/>
           <p:nvPr/>
         </p:nvSpPr>
@@ -16474,7 +16474,7 @@
       </p:sp>
       <p:sp>
         <p:nvSpPr>
-          <p:cNvPr id="216" name="Google Shape;216;p38"/>
+          <p:cNvPr id="220" name="Google Shape;220;p38"/>
           <p:cNvSpPr txBox="1"/>
           <p:nvPr/>
         </p:nvSpPr>
@@ -16526,7 +16526,7 @@
   <p:cSld>
     <p:spTree>
       <p:nvGrpSpPr>
-        <p:cNvPr id="220" name="Shape 220"/>
+        <p:cNvPr id="224" name="Shape 224"/>
         <p:cNvGrpSpPr/>
         <p:nvPr/>
       </p:nvGrpSpPr>
@@ -16540,7 +16540,7 @@
       </p:grpSpPr>
       <p:sp>
         <p:nvSpPr>
-          <p:cNvPr id="221" name="Google Shape;221;p39"/>
+          <p:cNvPr id="225" name="Google Shape;225;p39"/>
           <p:cNvSpPr txBox="1"/>
           <p:nvPr>
             <p:ph type="title"/>
@@ -16580,7 +16580,7 @@
       </p:sp>
       <p:sp>
         <p:nvSpPr>
-          <p:cNvPr id="222" name="Google Shape;222;p39"/>
+          <p:cNvPr id="226" name="Google Shape;226;p39"/>
           <p:cNvSpPr txBox="1"/>
           <p:nvPr/>
         </p:nvSpPr>
@@ -16658,7 +16658,7 @@
       </p:sp>
       <p:sp>
         <p:nvSpPr>
-          <p:cNvPr id="223" name="Google Shape;223;p39"/>
+          <p:cNvPr id="227" name="Google Shape;227;p39"/>
           <p:cNvSpPr txBox="1"/>
           <p:nvPr/>
         </p:nvSpPr>
@@ -16736,7 +16736,7 @@
       </p:sp>
       <p:sp>
         <p:nvSpPr>
-          <p:cNvPr id="224" name="Google Shape;224;p39"/>
+          <p:cNvPr id="228" name="Google Shape;228;p39"/>
           <p:cNvSpPr txBox="1"/>
           <p:nvPr/>
         </p:nvSpPr>
@@ -16866,7 +16866,7 @@
       </p:sp>
       <p:sp>
         <p:nvSpPr>
-          <p:cNvPr id="225" name="Google Shape;225;p39"/>
+          <p:cNvPr id="229" name="Google Shape;229;p39"/>
           <p:cNvSpPr/>
           <p:nvPr/>
         </p:nvSpPr>
@@ -16917,7 +16917,7 @@
       </p:sp>
       <p:sp>
         <p:nvSpPr>
-          <p:cNvPr id="226" name="Google Shape;226;p39"/>
+          <p:cNvPr id="230" name="Google Shape;230;p39"/>
           <p:cNvSpPr/>
           <p:nvPr/>
         </p:nvSpPr>
@@ -16967,7 +16967,7 @@
       </p:sp>
       <p:sp>
         <p:nvSpPr>
-          <p:cNvPr id="227" name="Google Shape;227;p39"/>
+          <p:cNvPr id="231" name="Google Shape;231;p39"/>
           <p:cNvSpPr/>
           <p:nvPr/>
         </p:nvSpPr>
@@ -17065,7 +17065,7 @@
       </p:sp>
       <p:sp>
         <p:nvSpPr>
-          <p:cNvPr id="228" name="Google Shape;228;p39"/>
+          <p:cNvPr id="232" name="Google Shape;232;p39"/>
           <p:cNvSpPr/>
           <p:nvPr/>
         </p:nvSpPr>
@@ -17115,7 +17115,7 @@
       </p:sp>
       <p:cxnSp>
         <p:nvCxnSpPr>
-          <p:cNvPr id="229" name="Google Shape;229;p39"/>
+          <p:cNvPr id="233" name="Google Shape;233;p39"/>
           <p:cNvCxnSpPr/>
           <p:nvPr/>
         </p:nvCxnSpPr>
@@ -17152,7 +17152,7 @@
   <p:cSld>
     <p:spTree>
       <p:nvGrpSpPr>
-        <p:cNvPr id="233" name="Shape 233"/>
+        <p:cNvPr id="237" name="Shape 237"/>
         <p:cNvGrpSpPr/>
         <p:nvPr/>
       </p:nvGrpSpPr>
@@ -17166,7 +17166,7 @@
       </p:grpSpPr>
       <p:sp>
         <p:nvSpPr>
-          <p:cNvPr id="234" name="Google Shape;234;p40"/>
+          <p:cNvPr id="238" name="Google Shape;238;p40"/>
           <p:cNvSpPr txBox="1"/>
           <p:nvPr>
             <p:ph type="title"/>
@@ -17206,7 +17206,7 @@
       </p:sp>
       <p:sp>
         <p:nvSpPr>
-          <p:cNvPr id="235" name="Google Shape;235;p40"/>
+          <p:cNvPr id="239" name="Google Shape;239;p40"/>
           <p:cNvSpPr txBox="1"/>
           <p:nvPr>
             <p:ph idx="1" type="body"/>
@@ -17722,7 +17722,7 @@
       </p:sp>
       <p:cxnSp>
         <p:nvCxnSpPr>
-          <p:cNvPr id="236" name="Google Shape;236;p40"/>
+          <p:cNvPr id="240" name="Google Shape;240;p40"/>
           <p:cNvCxnSpPr/>
           <p:nvPr/>
         </p:nvCxnSpPr>
@@ -17748,7 +17748,7 @@
       </p:cxnSp>
       <p:sp>
         <p:nvSpPr>
-          <p:cNvPr id="237" name="Google Shape;237;p40"/>
+          <p:cNvPr id="241" name="Google Shape;241;p40"/>
           <p:cNvSpPr/>
           <p:nvPr/>
         </p:nvSpPr>
@@ -17795,7 +17795,7 @@
       </p:sp>
       <p:sp>
         <p:nvSpPr>
-          <p:cNvPr id="238" name="Google Shape;238;p40"/>
+          <p:cNvPr id="242" name="Google Shape;242;p40"/>
           <p:cNvSpPr txBox="1"/>
           <p:nvPr/>
         </p:nvSpPr>
@@ -17845,7 +17845,7 @@
       </p:sp>
       <p:sp>
         <p:nvSpPr>
-          <p:cNvPr id="239" name="Google Shape;239;p40"/>
+          <p:cNvPr id="243" name="Google Shape;243;p40"/>
           <p:cNvSpPr/>
           <p:nvPr/>
         </p:nvSpPr>
@@ -17892,7 +17892,7 @@
       </p:sp>
       <p:cxnSp>
         <p:nvCxnSpPr>
-          <p:cNvPr id="240" name="Google Shape;240;p40"/>
+          <p:cNvPr id="244" name="Google Shape;244;p40"/>
           <p:cNvCxnSpPr/>
           <p:nvPr/>
         </p:nvCxnSpPr>
@@ -17918,7 +17918,7 @@
       </p:cxnSp>
       <p:sp>
         <p:nvSpPr>
-          <p:cNvPr id="241" name="Google Shape;241;p40"/>
+          <p:cNvPr id="245" name="Google Shape;245;p40"/>
           <p:cNvSpPr txBox="1"/>
           <p:nvPr/>
         </p:nvSpPr>
@@ -17968,7 +17968,7 @@
       </p:sp>
       <p:sp>
         <p:nvSpPr>
-          <p:cNvPr id="242" name="Google Shape;242;p40"/>
+          <p:cNvPr id="246" name="Google Shape;246;p40"/>
           <p:cNvSpPr/>
           <p:nvPr/>
         </p:nvSpPr>
@@ -18015,7 +18015,7 @@
       </p:sp>
       <p:cxnSp>
         <p:nvCxnSpPr>
-          <p:cNvPr id="243" name="Google Shape;243;p40"/>
+          <p:cNvPr id="247" name="Google Shape;247;p40"/>
           <p:cNvCxnSpPr/>
           <p:nvPr/>
         </p:nvCxnSpPr>
@@ -18041,7 +18041,7 @@
       </p:cxnSp>
       <p:sp>
         <p:nvSpPr>
-          <p:cNvPr id="244" name="Google Shape;244;p40"/>
+          <p:cNvPr id="248" name="Google Shape;248;p40"/>
           <p:cNvSpPr txBox="1"/>
           <p:nvPr/>
         </p:nvSpPr>
@@ -18102,7 +18102,7 @@
   <p:cSld>
     <p:spTree>
       <p:nvGrpSpPr>
-        <p:cNvPr id="248" name="Shape 248"/>
+        <p:cNvPr id="252" name="Shape 252"/>
         <p:cNvGrpSpPr/>
         <p:nvPr/>
       </p:nvGrpSpPr>
@@ -18116,7 +18116,7 @@
       </p:grpSpPr>
       <p:pic>
         <p:nvPicPr>
-          <p:cNvPr id="249" name="Google Shape;249;p41"/>
+          <p:cNvPr id="253" name="Google Shape;253;p41"/>
           <p:cNvPicPr preferRelativeResize="0"/>
           <p:nvPr/>
         </p:nvPicPr>
@@ -18144,7 +18144,7 @@
       </p:pic>
       <p:sp>
         <p:nvSpPr>
-          <p:cNvPr id="250" name="Google Shape;250;p41"/>
+          <p:cNvPr id="254" name="Google Shape;254;p41"/>
           <p:cNvSpPr txBox="1"/>
           <p:nvPr>
             <p:ph type="title"/>
@@ -18188,7 +18188,7 @@
       </p:sp>
       <p:cxnSp>
         <p:nvCxnSpPr>
-          <p:cNvPr id="251" name="Google Shape;251;p41"/>
+          <p:cNvPr id="255" name="Google Shape;255;p41"/>
           <p:cNvCxnSpPr/>
           <p:nvPr/>
         </p:nvCxnSpPr>
@@ -18214,7 +18214,7 @@
       </p:cxnSp>
       <p:sp>
         <p:nvSpPr>
-          <p:cNvPr id="252" name="Google Shape;252;p41"/>
+          <p:cNvPr id="256" name="Google Shape;256;p41"/>
           <p:cNvSpPr txBox="1"/>
           <p:nvPr/>
         </p:nvSpPr>
@@ -18272,7 +18272,7 @@
       </p:sp>
       <p:cxnSp>
         <p:nvCxnSpPr>
-          <p:cNvPr id="253" name="Google Shape;253;p41"/>
+          <p:cNvPr id="257" name="Google Shape;257;p41"/>
           <p:cNvCxnSpPr/>
           <p:nvPr/>
         </p:nvCxnSpPr>
@@ -18298,7 +18298,7 @@
       </p:cxnSp>
       <p:sp>
         <p:nvSpPr>
-          <p:cNvPr id="254" name="Google Shape;254;p41"/>
+          <p:cNvPr id="258" name="Google Shape;258;p41"/>
           <p:cNvSpPr txBox="1"/>
           <p:nvPr/>
         </p:nvSpPr>
@@ -18356,7 +18356,7 @@
       </p:sp>
       <p:cxnSp>
         <p:nvCxnSpPr>
-          <p:cNvPr id="255" name="Google Shape;255;p41"/>
+          <p:cNvPr id="259" name="Google Shape;259;p41"/>
           <p:cNvCxnSpPr/>
           <p:nvPr/>
         </p:nvCxnSpPr>
@@ -18382,7 +18382,7 @@
       </p:cxnSp>
       <p:sp>
         <p:nvSpPr>
-          <p:cNvPr id="256" name="Google Shape;256;p41"/>
+          <p:cNvPr id="260" name="Google Shape;260;p41"/>
           <p:cNvSpPr txBox="1"/>
           <p:nvPr/>
         </p:nvSpPr>
@@ -18443,7 +18443,7 @@
   <p:cSld>
     <p:spTree>
       <p:nvGrpSpPr>
-        <p:cNvPr id="260" name="Shape 260"/>
+        <p:cNvPr id="264" name="Shape 264"/>
         <p:cNvGrpSpPr/>
         <p:nvPr/>
       </p:nvGrpSpPr>
@@ -18457,7 +18457,7 @@
       </p:grpSpPr>
       <p:sp>
         <p:nvSpPr>
-          <p:cNvPr id="261" name="Google Shape;261;p42"/>
+          <p:cNvPr id="265" name="Google Shape;265;p42"/>
           <p:cNvSpPr txBox="1"/>
           <p:nvPr>
             <p:ph type="title"/>
@@ -18549,7 +18549,7 @@
       </p:sp>
       <p:sp>
         <p:nvSpPr>
-          <p:cNvPr id="262" name="Google Shape;262;p42"/>
+          <p:cNvPr id="266" name="Google Shape;266;p42"/>
           <p:cNvSpPr txBox="1"/>
           <p:nvPr>
             <p:ph idx="1" type="body"/>
@@ -19393,7 +19393,7 @@
       </p:sp>
       <p:sp>
         <p:nvSpPr>
-          <p:cNvPr id="263" name="Google Shape;263;p42"/>
+          <p:cNvPr id="267" name="Google Shape;267;p42"/>
           <p:cNvSpPr txBox="1"/>
           <p:nvPr/>
         </p:nvSpPr>
@@ -19671,121 +19671,16 @@
               <a:t>BBC micro:bit 						</a:t>
             </a:r>
             <a:r>
-              <a:rPr lang="en" sz="2700"/>
-              <a:t>Thonny</a:t>
+              <a:rPr lang="en" sz="2000"/>
+              <a:t>Change to connect to micro:bit</a:t>
             </a:r>
-            <a:r>
-              <a:rPr lang="en" sz="3400"/>
-              <a:t> </a:t>
-            </a:r>
-            <a:r>
-              <a:rPr lang="en" sz="2700"/>
-              <a:t>Python Editor</a:t>
-            </a:r>
-            <a:endParaRPr sz="2700"/>
+            <a:endParaRPr sz="2000"/>
           </a:p>
         </p:txBody>
       </p:sp>
       <p:pic>
         <p:nvPicPr>
           <p:cNvPr id="124" name="Google Shape;124;p28"/>
-          <p:cNvPicPr preferRelativeResize="0"/>
-          <p:nvPr/>
-        </p:nvPicPr>
-        <p:blipFill>
-          <a:blip r:embed="rId3">
-            <a:alphaModFix/>
-          </a:blip>
-          <a:stretch>
-            <a:fillRect/>
-          </a:stretch>
-        </p:blipFill>
-        <p:spPr>
-          <a:xfrm>
-            <a:off x="540500" y="712540"/>
-            <a:ext cx="7642408" cy="4126258"/>
-          </a:xfrm>
-          <a:prstGeom prst="rect">
-            <a:avLst/>
-          </a:prstGeom>
-          <a:noFill/>
-          <a:ln>
-            <a:noFill/>
-          </a:ln>
-        </p:spPr>
-      </p:pic>
-    </p:spTree>
-  </p:cSld>
-  <p:clrMapOvr>
-    <a:masterClrMapping/>
-  </p:clrMapOvr>
-</p:sld>
-</file>
-
-<file path=ppt/slides/slide4.xml><?xml version="1.0" encoding="utf-8"?>
-<p:sld xmlns:a="http://schemas.openxmlformats.org/drawingml/2006/main" xmlns:r="http://schemas.openxmlformats.org/officeDocument/2006/relationships" xmlns:mc="http://schemas.openxmlformats.org/markup-compatibility/2006" xmlns:mv="urn:schemas-microsoft-com:mac:vml" xmlns:p="http://schemas.openxmlformats.org/presentationml/2006/main" xmlns:c="http://schemas.openxmlformats.org/drawingml/2006/chart" xmlns:dgm="http://schemas.openxmlformats.org/drawingml/2006/diagram" xmlns:o="urn:schemas-microsoft-com:office:office" xmlns:v="urn:schemas-microsoft-com:vml" xmlns:pvml="urn:schemas-microsoft-com:office:powerpoint" xmlns:com="http://schemas.openxmlformats.org/drawingml/2006/compatibility" xmlns:p14="http://schemas.microsoft.com/office/powerpoint/2010/main" xmlns:p15="http://schemas.microsoft.com/office/powerpoint/2012/main" xmlns:ahyp="http://schemas.microsoft.com/office/drawing/2018/hyperlinkcolor">
-  <p:cSld>
-    <p:spTree>
-      <p:nvGrpSpPr>
-        <p:cNvPr id="128" name="Shape 128"/>
-        <p:cNvGrpSpPr/>
-        <p:nvPr/>
-      </p:nvGrpSpPr>
-      <p:grpSpPr>
-        <a:xfrm>
-          <a:off x="0" y="0"/>
-          <a:ext cx="0" cy="0"/>
-          <a:chOff x="0" y="0"/>
-          <a:chExt cx="0" cy="0"/>
-        </a:xfrm>
-      </p:grpSpPr>
-      <p:sp>
-        <p:nvSpPr>
-          <p:cNvPr id="129" name="Google Shape;129;p29"/>
-          <p:cNvSpPr txBox="1"/>
-          <p:nvPr>
-            <p:ph type="title"/>
-          </p:nvPr>
-        </p:nvSpPr>
-        <p:spPr>
-          <a:xfrm>
-            <a:off x="171375" y="132350"/>
-            <a:ext cx="8848200" cy="580200"/>
-          </a:xfrm>
-          <a:prstGeom prst="rect">
-            <a:avLst/>
-          </a:prstGeom>
-        </p:spPr>
-        <p:txBody>
-          <a:bodyPr anchorCtr="0" anchor="b" bIns="91425" lIns="91425" spcFirstLastPara="1" rIns="91425" wrap="square" tIns="91425">
-            <a:noAutofit/>
-          </a:bodyPr>
-          <a:lstStyle/>
-          <a:p>
-            <a:pPr indent="0" lvl="0" marL="0" rtl="0" algn="l">
-              <a:spcBef>
-                <a:spcPts val="0"/>
-              </a:spcBef>
-              <a:spcAft>
-                <a:spcPts val="0"/>
-              </a:spcAft>
-              <a:buNone/>
-            </a:pPr>
-            <a:r>
-              <a:rPr lang="en" sz="3400"/>
-              <a:t>BBC micro:bit 						</a:t>
-            </a:r>
-            <a:r>
-              <a:rPr lang="en" sz="2000"/>
-              <a:t>Change to connect to micro:bit</a:t>
-            </a:r>
-            <a:endParaRPr sz="2000"/>
-          </a:p>
-        </p:txBody>
-      </p:sp>
-      <p:pic>
-        <p:nvPicPr>
-          <p:cNvPr id="130" name="Google Shape;130;p29"/>
           <p:cNvPicPr preferRelativeResize="0"/>
           <p:nvPr/>
         </p:nvPicPr>
@@ -19813,7 +19708,7 @@
       </p:pic>
       <p:cxnSp>
         <p:nvCxnSpPr>
-          <p:cNvPr id="131" name="Google Shape;131;p29"/>
+          <p:cNvPr id="125" name="Google Shape;125;p28"/>
           <p:cNvCxnSpPr/>
           <p:nvPr/>
         </p:nvCxnSpPr>
@@ -19839,7 +19734,7 @@
       </p:cxnSp>
       <p:pic>
         <p:nvPicPr>
-          <p:cNvPr id="132" name="Google Shape;132;p29"/>
+          <p:cNvPr id="126" name="Google Shape;126;p28"/>
           <p:cNvPicPr preferRelativeResize="0"/>
           <p:nvPr/>
         </p:nvPicPr>
@@ -19867,7 +19762,7 @@
       </p:pic>
       <p:sp>
         <p:nvSpPr>
-          <p:cNvPr id="133" name="Google Shape;133;p29"/>
+          <p:cNvPr id="127" name="Google Shape;127;p28"/>
           <p:cNvSpPr/>
           <p:nvPr/>
         </p:nvSpPr>
@@ -19925,12 +19820,12 @@
 </p:sld>
 </file>
 
-<file path=ppt/slides/slide5.xml><?xml version="1.0" encoding="utf-8"?>
+<file path=ppt/slides/slide4.xml><?xml version="1.0" encoding="utf-8"?>
 <p:sld xmlns:a="http://schemas.openxmlformats.org/drawingml/2006/main" xmlns:r="http://schemas.openxmlformats.org/officeDocument/2006/relationships" xmlns:mc="http://schemas.openxmlformats.org/markup-compatibility/2006" xmlns:mv="urn:schemas-microsoft-com:mac:vml" xmlns:p="http://schemas.openxmlformats.org/presentationml/2006/main" xmlns:c="http://schemas.openxmlformats.org/drawingml/2006/chart" xmlns:dgm="http://schemas.openxmlformats.org/drawingml/2006/diagram" xmlns:o="urn:schemas-microsoft-com:office:office" xmlns:v="urn:schemas-microsoft-com:vml" xmlns:pvml="urn:schemas-microsoft-com:office:powerpoint" xmlns:com="http://schemas.openxmlformats.org/drawingml/2006/compatibility" xmlns:p14="http://schemas.microsoft.com/office/powerpoint/2010/main" xmlns:p15="http://schemas.microsoft.com/office/powerpoint/2012/main" xmlns:ahyp="http://schemas.microsoft.com/office/drawing/2018/hyperlinkcolor">
   <p:cSld>
     <p:spTree>
       <p:nvGrpSpPr>
-        <p:cNvPr id="137" name="Shape 137"/>
+        <p:cNvPr id="131" name="Shape 131"/>
         <p:cNvGrpSpPr/>
         <p:nvPr/>
       </p:nvGrpSpPr>
@@ -19944,7 +19839,7 @@
       </p:grpSpPr>
       <p:sp>
         <p:nvSpPr>
-          <p:cNvPr id="138" name="Google Shape;138;p30"/>
+          <p:cNvPr id="132" name="Google Shape;132;p29"/>
           <p:cNvSpPr txBox="1"/>
           <p:nvPr>
             <p:ph type="title"/>
@@ -19988,7 +19883,7 @@
       </p:sp>
       <p:pic>
         <p:nvPicPr>
-          <p:cNvPr id="139" name="Google Shape;139;p30"/>
+          <p:cNvPr id="133" name="Google Shape;133;p29"/>
           <p:cNvPicPr preferRelativeResize="0"/>
           <p:nvPr/>
         </p:nvPicPr>
@@ -20016,7 +19911,7 @@
       </p:pic>
       <p:cxnSp>
         <p:nvCxnSpPr>
-          <p:cNvPr id="140" name="Google Shape;140;p30"/>
+          <p:cNvPr id="134" name="Google Shape;134;p29"/>
           <p:cNvCxnSpPr/>
           <p:nvPr/>
         </p:nvCxnSpPr>
@@ -20048,12 +19943,12 @@
 </p:sld>
 </file>
 
-<file path=ppt/slides/slide6.xml><?xml version="1.0" encoding="utf-8"?>
+<file path=ppt/slides/slide5.xml><?xml version="1.0" encoding="utf-8"?>
 <p:sld xmlns:a="http://schemas.openxmlformats.org/drawingml/2006/main" xmlns:r="http://schemas.openxmlformats.org/officeDocument/2006/relationships" xmlns:mc="http://schemas.openxmlformats.org/markup-compatibility/2006" xmlns:mv="urn:schemas-microsoft-com:mac:vml" xmlns:p="http://schemas.openxmlformats.org/presentationml/2006/main" xmlns:c="http://schemas.openxmlformats.org/drawingml/2006/chart" xmlns:dgm="http://schemas.openxmlformats.org/drawingml/2006/diagram" xmlns:o="urn:schemas-microsoft-com:office:office" xmlns:v="urn:schemas-microsoft-com:vml" xmlns:pvml="urn:schemas-microsoft-com:office:powerpoint" xmlns:com="http://schemas.openxmlformats.org/drawingml/2006/compatibility" xmlns:p14="http://schemas.microsoft.com/office/powerpoint/2010/main" xmlns:p15="http://schemas.microsoft.com/office/powerpoint/2012/main" xmlns:ahyp="http://schemas.microsoft.com/office/drawing/2018/hyperlinkcolor">
   <p:cSld>
     <p:spTree>
       <p:nvGrpSpPr>
-        <p:cNvPr id="144" name="Shape 144"/>
+        <p:cNvPr id="138" name="Shape 138"/>
         <p:cNvGrpSpPr/>
         <p:nvPr/>
       </p:nvGrpSpPr>
@@ -20067,7 +19962,248 @@
       </p:grpSpPr>
       <p:sp>
         <p:nvSpPr>
-          <p:cNvPr id="145" name="Google Shape;145;p31"/>
+          <p:cNvPr id="139" name="Google Shape;139;p30"/>
+          <p:cNvSpPr txBox="1"/>
+          <p:nvPr>
+            <p:ph type="title"/>
+          </p:nvPr>
+        </p:nvSpPr>
+        <p:spPr>
+          <a:xfrm>
+            <a:off x="171375" y="132350"/>
+            <a:ext cx="8848200" cy="580200"/>
+          </a:xfrm>
+          <a:prstGeom prst="rect">
+            <a:avLst/>
+          </a:prstGeom>
+        </p:spPr>
+        <p:txBody>
+          <a:bodyPr anchorCtr="0" anchor="b" bIns="91425" lIns="91425" spcFirstLastPara="1" rIns="91425" wrap="square" tIns="91425">
+            <a:noAutofit/>
+          </a:bodyPr>
+          <a:lstStyle/>
+          <a:p>
+            <a:pPr indent="0" lvl="0" marL="0" rtl="0" algn="l">
+              <a:spcBef>
+                <a:spcPts val="0"/>
+              </a:spcBef>
+              <a:spcAft>
+                <a:spcPts val="0"/>
+              </a:spcAft>
+              <a:buNone/>
+            </a:pPr>
+            <a:r>
+              <a:rPr lang="en" sz="3400"/>
+              <a:t>BBC micro:bit 						</a:t>
+            </a:r>
+            <a:r>
+              <a:rPr lang="en" sz="2700"/>
+              <a:t>Thonny</a:t>
+            </a:r>
+            <a:r>
+              <a:rPr lang="en" sz="3400"/>
+              <a:t> </a:t>
+            </a:r>
+            <a:r>
+              <a:rPr lang="en" sz="2700"/>
+              <a:t>Python Editor</a:t>
+            </a:r>
+            <a:endParaRPr sz="2700"/>
+          </a:p>
+        </p:txBody>
+      </p:sp>
+      <p:pic>
+        <p:nvPicPr>
+          <p:cNvPr id="140" name="Google Shape;140;p30"/>
+          <p:cNvPicPr preferRelativeResize="0"/>
+          <p:nvPr/>
+        </p:nvPicPr>
+        <p:blipFill>
+          <a:blip r:embed="rId3">
+            <a:alphaModFix/>
+          </a:blip>
+          <a:stretch>
+            <a:fillRect/>
+          </a:stretch>
+        </p:blipFill>
+        <p:spPr>
+          <a:xfrm>
+            <a:off x="692250" y="632415"/>
+            <a:ext cx="7642408" cy="4126258"/>
+          </a:xfrm>
+          <a:prstGeom prst="rect">
+            <a:avLst/>
+          </a:prstGeom>
+          <a:noFill/>
+          <a:ln>
+            <a:noFill/>
+          </a:ln>
+        </p:spPr>
+      </p:pic>
+      <p:cxnSp>
+        <p:nvCxnSpPr>
+          <p:cNvPr id="141" name="Google Shape;141;p30"/>
+          <p:cNvCxnSpPr/>
+          <p:nvPr/>
+        </p:nvCxnSpPr>
+        <p:spPr>
+          <a:xfrm flipH="1">
+            <a:off x="3512175" y="912450"/>
+            <a:ext cx="2031300" cy="283500"/>
+          </a:xfrm>
+          <a:prstGeom prst="straightConnector1">
+            <a:avLst/>
+          </a:prstGeom>
+          <a:noFill/>
+          <a:ln cap="flat" cmpd="sng" w="9525">
+            <a:solidFill>
+              <a:srgbClr val="4BA173"/>
+            </a:solidFill>
+            <a:prstDash val="solid"/>
+            <a:round/>
+            <a:headEnd len="med" w="med" type="none"/>
+            <a:tailEnd len="med" w="med" type="triangle"/>
+          </a:ln>
+        </p:spPr>
+      </p:cxnSp>
+      <p:sp>
+        <p:nvSpPr>
+          <p:cNvPr id="142" name="Google Shape;142;p30"/>
+          <p:cNvSpPr txBox="1"/>
+          <p:nvPr/>
+        </p:nvSpPr>
+        <p:spPr>
+          <a:xfrm>
+            <a:off x="5499750" y="712525"/>
+            <a:ext cx="1631100" cy="356400"/>
+          </a:xfrm>
+          <a:prstGeom prst="rect">
+            <a:avLst/>
+          </a:prstGeom>
+          <a:noFill/>
+          <a:ln>
+            <a:noFill/>
+          </a:ln>
+        </p:spPr>
+        <p:txBody>
+          <a:bodyPr anchorCtr="0" anchor="b" bIns="91425" lIns="91425" spcFirstLastPara="1" rIns="91425" wrap="square" tIns="91425">
+            <a:noAutofit/>
+          </a:bodyPr>
+          <a:lstStyle/>
+          <a:p>
+            <a:pPr indent="0" lvl="0" marL="0" rtl="0" algn="l">
+              <a:spcBef>
+                <a:spcPts val="0"/>
+              </a:spcBef>
+              <a:spcAft>
+                <a:spcPts val="0"/>
+              </a:spcAft>
+              <a:buNone/>
+            </a:pPr>
+            <a:r>
+              <a:rPr lang="en"/>
+              <a:t>Program tabs</a:t>
+            </a:r>
+            <a:endParaRPr/>
+          </a:p>
+        </p:txBody>
+      </p:sp>
+      <p:cxnSp>
+        <p:nvCxnSpPr>
+          <p:cNvPr id="143" name="Google Shape;143;p30"/>
+          <p:cNvCxnSpPr/>
+          <p:nvPr/>
+        </p:nvCxnSpPr>
+        <p:spPr>
+          <a:xfrm flipH="1">
+            <a:off x="3006201" y="3958535"/>
+            <a:ext cx="3362100" cy="469200"/>
+          </a:xfrm>
+          <a:prstGeom prst="straightConnector1">
+            <a:avLst/>
+          </a:prstGeom>
+          <a:noFill/>
+          <a:ln cap="flat" cmpd="sng" w="15775">
+            <a:solidFill>
+              <a:srgbClr val="4BA173"/>
+            </a:solidFill>
+            <a:prstDash val="solid"/>
+            <a:round/>
+            <a:headEnd len="med" w="med" type="none"/>
+            <a:tailEnd len="med" w="med" type="triangle"/>
+          </a:ln>
+        </p:spPr>
+      </p:cxnSp>
+      <p:sp>
+        <p:nvSpPr>
+          <p:cNvPr id="144" name="Google Shape;144;p30"/>
+          <p:cNvSpPr txBox="1"/>
+          <p:nvPr/>
+        </p:nvSpPr>
+        <p:spPr>
+          <a:xfrm>
+            <a:off x="6264654" y="3614800"/>
+            <a:ext cx="2699700" cy="589800"/>
+          </a:xfrm>
+          <a:prstGeom prst="rect">
+            <a:avLst/>
+          </a:prstGeom>
+          <a:noFill/>
+          <a:ln>
+            <a:noFill/>
+          </a:ln>
+        </p:spPr>
+        <p:txBody>
+          <a:bodyPr anchorCtr="0" anchor="b" bIns="151325" lIns="151325" spcFirstLastPara="1" rIns="151325" wrap="square" tIns="151325">
+            <a:noAutofit/>
+          </a:bodyPr>
+          <a:lstStyle/>
+          <a:p>
+            <a:pPr indent="0" lvl="0" marL="0" rtl="0" algn="l">
+              <a:spcBef>
+                <a:spcPts val="0"/>
+              </a:spcBef>
+              <a:spcAft>
+                <a:spcPts val="0"/>
+              </a:spcAft>
+              <a:buNone/>
+            </a:pPr>
+            <a:r>
+              <a:rPr lang="en" sz="2317"/>
+              <a:t>REPL</a:t>
+            </a:r>
+            <a:endParaRPr sz="2317"/>
+          </a:p>
+        </p:txBody>
+      </p:sp>
+    </p:spTree>
+  </p:cSld>
+  <p:clrMapOvr>
+    <a:masterClrMapping/>
+  </p:clrMapOvr>
+</p:sld>
+</file>
+
+<file path=ppt/slides/slide6.xml><?xml version="1.0" encoding="utf-8"?>
+<p:sld xmlns:a="http://schemas.openxmlformats.org/drawingml/2006/main" xmlns:r="http://schemas.openxmlformats.org/officeDocument/2006/relationships" xmlns:mc="http://schemas.openxmlformats.org/markup-compatibility/2006" xmlns:mv="urn:schemas-microsoft-com:mac:vml" xmlns:p="http://schemas.openxmlformats.org/presentationml/2006/main" xmlns:c="http://schemas.openxmlformats.org/drawingml/2006/chart" xmlns:dgm="http://schemas.openxmlformats.org/drawingml/2006/diagram" xmlns:o="urn:schemas-microsoft-com:office:office" xmlns:v="urn:schemas-microsoft-com:vml" xmlns:pvml="urn:schemas-microsoft-com:office:powerpoint" xmlns:com="http://schemas.openxmlformats.org/drawingml/2006/compatibility" xmlns:p14="http://schemas.microsoft.com/office/powerpoint/2010/main" xmlns:p15="http://schemas.microsoft.com/office/powerpoint/2012/main" xmlns:ahyp="http://schemas.microsoft.com/office/drawing/2018/hyperlinkcolor">
+  <p:cSld>
+    <p:spTree>
+      <p:nvGrpSpPr>
+        <p:cNvPr id="148" name="Shape 148"/>
+        <p:cNvGrpSpPr/>
+        <p:nvPr/>
+      </p:nvGrpSpPr>
+      <p:grpSpPr>
+        <a:xfrm>
+          <a:off x="0" y="0"/>
+          <a:ext cx="0" cy="0"/>
+          <a:chOff x="0" y="0"/>
+          <a:chExt cx="0" cy="0"/>
+        </a:xfrm>
+      </p:grpSpPr>
+      <p:sp>
+        <p:nvSpPr>
+          <p:cNvPr id="149" name="Google Shape;149;p31"/>
           <p:cNvSpPr txBox="1"/>
           <p:nvPr>
             <p:ph type="title"/>
@@ -20107,7 +20243,7 @@
       </p:sp>
       <p:sp>
         <p:nvSpPr>
-          <p:cNvPr id="146" name="Google Shape;146;p31"/>
+          <p:cNvPr id="150" name="Google Shape;150;p31"/>
           <p:cNvSpPr txBox="1"/>
           <p:nvPr>
             <p:ph idx="1" type="body"/>
@@ -20460,7 +20596,7 @@
   <p:cSld>
     <p:spTree>
       <p:nvGrpSpPr>
-        <p:cNvPr id="150" name="Shape 150"/>
+        <p:cNvPr id="154" name="Shape 154"/>
         <p:cNvGrpSpPr/>
         <p:nvPr/>
       </p:nvGrpSpPr>
@@ -20474,7 +20610,7 @@
       </p:grpSpPr>
       <p:sp>
         <p:nvSpPr>
-          <p:cNvPr id="151" name="Google Shape;151;p32"/>
+          <p:cNvPr id="155" name="Google Shape;155;p32"/>
           <p:cNvSpPr txBox="1"/>
           <p:nvPr>
             <p:ph type="title"/>
@@ -20514,7 +20650,7 @@
       </p:sp>
       <p:sp>
         <p:nvSpPr>
-          <p:cNvPr id="152" name="Google Shape;152;p32"/>
+          <p:cNvPr id="156" name="Google Shape;156;p32"/>
           <p:cNvSpPr txBox="1"/>
           <p:nvPr>
             <p:ph idx="1" type="body"/>
@@ -20970,7 +21106,7 @@
   <p:cSld>
     <p:spTree>
       <p:nvGrpSpPr>
-        <p:cNvPr id="156" name="Shape 156"/>
+        <p:cNvPr id="160" name="Shape 160"/>
         <p:cNvGrpSpPr/>
         <p:nvPr/>
       </p:nvGrpSpPr>
@@ -20984,7 +21120,7 @@
       </p:grpSpPr>
       <p:sp>
         <p:nvSpPr>
-          <p:cNvPr id="157" name="Google Shape;157;p33"/>
+          <p:cNvPr id="161" name="Google Shape;161;p33"/>
           <p:cNvSpPr txBox="1"/>
           <p:nvPr>
             <p:ph type="title"/>
@@ -21024,7 +21160,7 @@
       </p:sp>
       <p:sp>
         <p:nvSpPr>
-          <p:cNvPr id="158" name="Google Shape;158;p33"/>
+          <p:cNvPr id="162" name="Google Shape;162;p33"/>
           <p:cNvSpPr txBox="1"/>
           <p:nvPr>
             <p:ph idx="1" type="body"/>
@@ -21159,6 +21295,52 @@
                 <a:cs typeface="Courier New"/>
                 <a:sym typeface="Courier New"/>
               </a:rPr>
+              <a:t> from microbit import *</a:t>
+            </a:r>
+            <a:endParaRPr b="1" sz="1400">
+              <a:latin typeface="Courier New"/>
+              <a:ea typeface="Courier New"/>
+              <a:cs typeface="Courier New"/>
+              <a:sym typeface="Courier New"/>
+            </a:endParaRPr>
+          </a:p>
+          <a:p>
+            <a:pPr indent="0" lvl="0" marL="0" rtl="0" algn="l">
+              <a:spcBef>
+                <a:spcPts val="0"/>
+              </a:spcBef>
+              <a:spcAft>
+                <a:spcPts val="0"/>
+              </a:spcAft>
+              <a:buNone/>
+            </a:pPr>
+            <a:r>
+              <a:t/>
+            </a:r>
+            <a:endParaRPr b="1" sz="1400">
+              <a:latin typeface="Courier New"/>
+              <a:ea typeface="Courier New"/>
+              <a:cs typeface="Courier New"/>
+              <a:sym typeface="Courier New"/>
+            </a:endParaRPr>
+          </a:p>
+          <a:p>
+            <a:pPr indent="0" lvl="0" marL="0" rtl="0" algn="l">
+              <a:spcBef>
+                <a:spcPts val="0"/>
+              </a:spcBef>
+              <a:spcAft>
+                <a:spcPts val="0"/>
+              </a:spcAft>
+              <a:buNone/>
+            </a:pPr>
+            <a:r>
+              <a:rPr b="1" lang="en" sz="1400">
+                <a:latin typeface="Courier New"/>
+                <a:ea typeface="Courier New"/>
+                <a:cs typeface="Courier New"/>
+                <a:sym typeface="Courier New"/>
+              </a:rPr>
               <a:t> display.scroll('Hello')</a:t>
             </a:r>
             <a:endParaRPr b="1" sz="1400">
@@ -21401,11 +21583,11 @@
 </file>
 
 <file path=ppt/slides/slide9.xml><?xml version="1.0" encoding="utf-8"?>
-<p:sld xmlns:a="http://schemas.openxmlformats.org/drawingml/2006/main" xmlns:r="http://schemas.openxmlformats.org/officeDocument/2006/relationships" xmlns:mc="http://schemas.openxmlformats.org/markup-compatibility/2006" xmlns:mv="urn:schemas-microsoft-com:mac:vml" xmlns:p="http://schemas.openxmlformats.org/presentationml/2006/main" xmlns:c="http://schemas.openxmlformats.org/drawingml/2006/chart" xmlns:dgm="http://schemas.openxmlformats.org/drawingml/2006/diagram" xmlns:o="urn:schemas-microsoft-com:office:office" xmlns:v="urn:schemas-microsoft-com:vml" xmlns:pvml="urn:schemas-microsoft-com:office:powerpoint" xmlns:com="http://schemas.openxmlformats.org/drawingml/2006/compatibility" xmlns:p14="http://schemas.microsoft.com/office/powerpoint/2010/main" xmlns:p15="http://schemas.microsoft.com/office/powerpoint/2012/main" xmlns:ahyp="http://schemas.microsoft.com/office/drawing/2018/hyperlinkcolor">
+<p:sld xmlns:a="http://schemas.openxmlformats.org/drawingml/2006/main" xmlns:r="http://schemas.openxmlformats.org/officeDocument/2006/relationships" xmlns:mc="http://schemas.openxmlformats.org/markup-compatibility/2006" xmlns:mv="urn:schemas-microsoft-com:mac:vml" xmlns:p="http://schemas.openxmlformats.org/presentationml/2006/main" xmlns:c="http://schemas.openxmlformats.org/drawingml/2006/chart" xmlns:dgm="http://schemas.openxmlformats.org/drawingml/2006/diagram" xmlns:o="urn:schemas-microsoft-com:office:office" xmlns:v="urn:schemas-microsoft-com:vml" xmlns:pvml="urn:schemas-microsoft-com:office:powerpoint" xmlns:com="http://schemas.openxmlformats.org/drawingml/2006/compatibility" xmlns:p14="http://schemas.microsoft.com/office/powerpoint/2010/main" xmlns:p15="http://schemas.microsoft.com/office/powerpoint/2012/main" xmlns:ahyp="http://schemas.microsoft.com/office/drawing/2018/hyperlinkcolor" show="0">
   <p:cSld>
     <p:spTree>
       <p:nvGrpSpPr>
-        <p:cNvPr id="162" name="Shape 162"/>
+        <p:cNvPr id="166" name="Shape 166"/>
         <p:cNvGrpSpPr/>
         <p:nvPr/>
       </p:nvGrpSpPr>
@@ -21419,7 +21601,7 @@
       </p:grpSpPr>
       <p:sp>
         <p:nvSpPr>
-          <p:cNvPr id="163" name="Google Shape;163;p34"/>
+          <p:cNvPr id="167" name="Google Shape;167;p34"/>
           <p:cNvSpPr txBox="1"/>
           <p:nvPr>
             <p:ph type="title"/>
@@ -21459,7 +21641,7 @@
       </p:sp>
       <p:sp>
         <p:nvSpPr>
-          <p:cNvPr id="164" name="Google Shape;164;p34"/>
+          <p:cNvPr id="168" name="Google Shape;168;p34"/>
           <p:cNvSpPr txBox="1"/>
           <p:nvPr>
             <p:ph idx="1" type="body"/>
@@ -21960,7 +22142,7 @@
       </p:sp>
       <p:cxnSp>
         <p:nvCxnSpPr>
-          <p:cNvPr id="165" name="Google Shape;165;p34"/>
+          <p:cNvPr id="169" name="Google Shape;169;p34"/>
           <p:cNvCxnSpPr/>
           <p:nvPr/>
         </p:nvCxnSpPr>
@@ -21986,7 +22168,7 @@
       </p:cxnSp>
       <p:sp>
         <p:nvSpPr>
-          <p:cNvPr id="166" name="Google Shape;166;p34"/>
+          <p:cNvPr id="170" name="Google Shape;170;p34"/>
           <p:cNvSpPr txBox="1"/>
           <p:nvPr/>
         </p:nvSpPr>
@@ -22052,7 +22234,7 @@
       </p:sp>
       <p:sp>
         <p:nvSpPr>
-          <p:cNvPr id="167" name="Google Shape;167;p34"/>
+          <p:cNvPr id="171" name="Google Shape;171;p34"/>
           <p:cNvSpPr/>
           <p:nvPr/>
         </p:nvSpPr>
@@ -22099,7 +22281,7 @@
       </p:sp>
       <p:cxnSp>
         <p:nvCxnSpPr>
-          <p:cNvPr id="168" name="Google Shape;168;p34"/>
+          <p:cNvPr id="172" name="Google Shape;172;p34"/>
           <p:cNvCxnSpPr/>
           <p:nvPr/>
         </p:nvCxnSpPr>
@@ -22125,7 +22307,7 @@
       </p:cxnSp>
       <p:sp>
         <p:nvSpPr>
-          <p:cNvPr id="169" name="Google Shape;169;p34"/>
+          <p:cNvPr id="173" name="Google Shape;173;p34"/>
           <p:cNvSpPr txBox="1"/>
           <p:nvPr/>
         </p:nvSpPr>
@@ -22175,7 +22357,7 @@
       </p:sp>
       <p:sp>
         <p:nvSpPr>
-          <p:cNvPr id="170" name="Google Shape;170;p34"/>
+          <p:cNvPr id="174" name="Google Shape;174;p34"/>
           <p:cNvSpPr/>
           <p:nvPr/>
         </p:nvSpPr>
@@ -22222,7 +22404,7 @@
       </p:sp>
       <p:cxnSp>
         <p:nvCxnSpPr>
-          <p:cNvPr id="171" name="Google Shape;171;p34"/>
+          <p:cNvPr id="175" name="Google Shape;175;p34"/>
           <p:cNvCxnSpPr/>
           <p:nvPr/>
         </p:nvCxnSpPr>
@@ -22248,7 +22430,7 @@
       </p:cxnSp>
       <p:sp>
         <p:nvSpPr>
-          <p:cNvPr id="172" name="Google Shape;172;p34"/>
+          <p:cNvPr id="176" name="Google Shape;176;p34"/>
           <p:cNvSpPr txBox="1"/>
           <p:nvPr/>
         </p:nvSpPr>
@@ -22298,7 +22480,7 @@
       </p:sp>
       <p:sp>
         <p:nvSpPr>
-          <p:cNvPr id="173" name="Google Shape;173;p34"/>
+          <p:cNvPr id="177" name="Google Shape;177;p34"/>
           <p:cNvSpPr/>
           <p:nvPr/>
         </p:nvSpPr>
@@ -22631,6 +22813,285 @@
 </file>
 
 <file path=ppt/theme/theme2.xml><?xml version="1.0" encoding="utf-8"?>
+<a:theme xmlns:a="http://schemas.openxmlformats.org/drawingml/2006/main" xmlns:r="http://schemas.openxmlformats.org/officeDocument/2006/relationships" name="Spearmint">
+  <a:themeElements>
+    <a:clrScheme name="Spearmint">
+      <a:dk1>
+        <a:srgbClr val="202729"/>
+      </a:dk1>
+      <a:lt1>
+        <a:srgbClr val="FFFFFF"/>
+      </a:lt1>
+      <a:dk2>
+        <a:srgbClr val="4BA173"/>
+      </a:dk2>
+      <a:lt2>
+        <a:srgbClr val="63D297"/>
+      </a:lt2>
+      <a:accent1>
+        <a:srgbClr val="353744"/>
+      </a:accent1>
+      <a:accent2>
+        <a:srgbClr val="424242"/>
+      </a:accent2>
+      <a:accent3>
+        <a:srgbClr val="616161"/>
+      </a:accent3>
+      <a:accent4>
+        <a:srgbClr val="999999"/>
+      </a:accent4>
+      <a:accent5>
+        <a:srgbClr val="FF5252"/>
+      </a:accent5>
+      <a:accent6>
+        <a:srgbClr val="FFF176"/>
+      </a:accent6>
+      <a:hlink>
+        <a:srgbClr val="FF5252"/>
+      </a:hlink>
+      <a:folHlink>
+        <a:srgbClr val="FF5252"/>
+      </a:folHlink>
+    </a:clrScheme>
+    <a:fontScheme name="Office">
+      <a:majorFont>
+        <a:latin typeface="Arial"/>
+        <a:ea typeface=""/>
+        <a:cs typeface=""/>
+        <a:font script="Jpan" typeface="ＭＳ Ｐゴシック"/>
+        <a:font script="Hang" typeface="맑은 고딕"/>
+        <a:font script="Hans" typeface="宋体"/>
+        <a:font script="Hant" typeface="新細明體"/>
+        <a:font script="Arab" typeface="Times New Roman"/>
+        <a:font script="Hebr" typeface="Times New Roman"/>
+        <a:font script="Thai" typeface="Angsana New"/>
+        <a:font script="Ethi" typeface="Nyala"/>
+        <a:font script="Beng" typeface="Vrinda"/>
+        <a:font script="Gujr" typeface="Shruti"/>
+        <a:font script="Khmr" typeface="MoolBoran"/>
+        <a:font script="Knda" typeface="Tunga"/>
+        <a:font script="Guru" typeface="Raavi"/>
+        <a:font script="Cans" typeface="Euphemia"/>
+        <a:font script="Cher" typeface="Plantagenet Cherokee"/>
+        <a:font script="Yiii" typeface="Microsoft Yi Baiti"/>
+        <a:font script="Tibt" typeface="Microsoft Himalaya"/>
+        <a:font script="Thaa" typeface="MV Boli"/>
+        <a:font script="Deva" typeface="Mangal"/>
+        <a:font script="Telu" typeface="Gautami"/>
+        <a:font script="Taml" typeface="Latha"/>
+        <a:font script="Syrc" typeface="Estrangelo Edessa"/>
+        <a:font script="Orya" typeface="Kalinga"/>
+        <a:font script="Mlym" typeface="Kartika"/>
+        <a:font script="Laoo" typeface="DokChampa"/>
+        <a:font script="Sinh" typeface="Iskoola Pota"/>
+        <a:font script="Mong" typeface="Mongolian Baiti"/>
+        <a:font script="Viet" typeface="Times New Roman"/>
+        <a:font script="Uigh" typeface="Microsoft Uighur"/>
+        <a:font script="Geor" typeface="Sylfaen"/>
+      </a:majorFont>
+      <a:minorFont>
+        <a:latin typeface="Arial"/>
+        <a:ea typeface=""/>
+        <a:cs typeface=""/>
+        <a:font script="Jpan" typeface="ＭＳ Ｐゴシック"/>
+        <a:font script="Hang" typeface="맑은 고딕"/>
+        <a:font script="Hans" typeface="宋体"/>
+        <a:font script="Hant" typeface="新細明體"/>
+        <a:font script="Arab" typeface="Arial"/>
+        <a:font script="Hebr" typeface="Arial"/>
+        <a:font script="Thai" typeface="Cordia New"/>
+        <a:font script="Ethi" typeface="Nyala"/>
+        <a:font script="Beng" typeface="Vrinda"/>
+        <a:font script="Gujr" typeface="Shruti"/>
+        <a:font script="Khmr" typeface="DaunPenh"/>
+        <a:font script="Knda" typeface="Tunga"/>
+        <a:font script="Guru" typeface="Raavi"/>
+        <a:font script="Cans" typeface="Euphemia"/>
+        <a:font script="Cher" typeface="Plantagenet Cherokee"/>
+        <a:font script="Yiii" typeface="Microsoft Yi Baiti"/>
+        <a:font script="Tibt" typeface="Microsoft Himalaya"/>
+        <a:font script="Thaa" typeface="MV Boli"/>
+        <a:font script="Deva" typeface="Mangal"/>
+        <a:font script="Telu" typeface="Gautami"/>
+        <a:font script="Taml" typeface="Latha"/>
+        <a:font script="Syrc" typeface="Estrangelo Edessa"/>
+        <a:font script="Orya" typeface="Kalinga"/>
+        <a:font script="Mlym" typeface="Kartika"/>
+        <a:font script="Laoo" typeface="DokChampa"/>
+        <a:font script="Sinh" typeface="Iskoola Pota"/>
+        <a:font script="Mong" typeface="Mongolian Baiti"/>
+        <a:font script="Viet" typeface="Arial"/>
+        <a:font script="Uigh" typeface="Microsoft Uighur"/>
+        <a:font script="Geor" typeface="Sylfaen"/>
+      </a:minorFont>
+    </a:fontScheme>
+    <a:fmtScheme name="Office">
+      <a:fillStyleLst>
+        <a:solidFill>
+          <a:schemeClr val="phClr"/>
+        </a:solidFill>
+        <a:gradFill rotWithShape="1">
+          <a:gsLst>
+            <a:gs pos="0">
+              <a:schemeClr val="phClr">
+                <a:tint val="50000"/>
+                <a:satMod val="300000"/>
+              </a:schemeClr>
+            </a:gs>
+            <a:gs pos="35000">
+              <a:schemeClr val="phClr">
+                <a:tint val="37000"/>
+                <a:satMod val="300000"/>
+              </a:schemeClr>
+            </a:gs>
+            <a:gs pos="100000">
+              <a:schemeClr val="phClr">
+                <a:tint val="15000"/>
+                <a:satMod val="350000"/>
+              </a:schemeClr>
+            </a:gs>
+          </a:gsLst>
+          <a:lin ang="16200000" scaled="1"/>
+        </a:gradFill>
+        <a:gradFill rotWithShape="1">
+          <a:gsLst>
+            <a:gs pos="0">
+              <a:schemeClr val="phClr">
+                <a:tint val="100000"/>
+                <a:shade val="100000"/>
+                <a:satMod val="130000"/>
+              </a:schemeClr>
+            </a:gs>
+            <a:gs pos="100000">
+              <a:schemeClr val="phClr">
+                <a:tint val="50000"/>
+                <a:shade val="100000"/>
+                <a:satMod val="350000"/>
+              </a:schemeClr>
+            </a:gs>
+          </a:gsLst>
+          <a:lin ang="16200000" scaled="0"/>
+        </a:gradFill>
+      </a:fillStyleLst>
+      <a:lnStyleLst>
+        <a:ln w="9525" cap="flat" cmpd="sng" algn="ctr">
+          <a:solidFill>
+            <a:schemeClr val="phClr">
+              <a:shade val="95000"/>
+              <a:satMod val="105000"/>
+            </a:schemeClr>
+          </a:solidFill>
+          <a:prstDash val="solid"/>
+        </a:ln>
+        <a:ln w="25400" cap="flat" cmpd="sng" algn="ctr">
+          <a:solidFill>
+            <a:schemeClr val="phClr"/>
+          </a:solidFill>
+          <a:prstDash val="solid"/>
+        </a:ln>
+        <a:ln w="38100" cap="flat" cmpd="sng" algn="ctr">
+          <a:solidFill>
+            <a:schemeClr val="phClr"/>
+          </a:solidFill>
+          <a:prstDash val="solid"/>
+        </a:ln>
+      </a:lnStyleLst>
+      <a:effectStyleLst>
+        <a:effectStyle>
+          <a:effectLst>
+            <a:outerShdw blurRad="40000" dist="20000" dir="5400000" rotWithShape="0">
+              <a:srgbClr val="000000">
+                <a:alpha val="38000"/>
+              </a:srgbClr>
+            </a:outerShdw>
+          </a:effectLst>
+        </a:effectStyle>
+        <a:effectStyle>
+          <a:effectLst>
+            <a:outerShdw blurRad="40000" dist="23000" dir="5400000" rotWithShape="0">
+              <a:srgbClr val="000000">
+                <a:alpha val="35000"/>
+              </a:srgbClr>
+            </a:outerShdw>
+          </a:effectLst>
+        </a:effectStyle>
+        <a:effectStyle>
+          <a:effectLst>
+            <a:outerShdw blurRad="40000" dist="23000" dir="5400000" rotWithShape="0">
+              <a:srgbClr val="000000">
+                <a:alpha val="35000"/>
+              </a:srgbClr>
+            </a:outerShdw>
+          </a:effectLst>
+          <a:scene3d>
+            <a:camera prst="orthographicFront">
+              <a:rot lat="0" lon="0" rev="0"/>
+            </a:camera>
+            <a:lightRig rig="threePt" dir="t">
+              <a:rot lat="0" lon="0" rev="1200000"/>
+            </a:lightRig>
+          </a:scene3d>
+          <a:sp3d>
+            <a:bevelT w="63500" h="25400"/>
+          </a:sp3d>
+        </a:effectStyle>
+      </a:effectStyleLst>
+      <a:bgFillStyleLst>
+        <a:solidFill>
+          <a:schemeClr val="phClr"/>
+        </a:solidFill>
+        <a:gradFill rotWithShape="1">
+          <a:gsLst>
+            <a:gs pos="0">
+              <a:schemeClr val="phClr">
+                <a:tint val="40000"/>
+                <a:satMod val="350000"/>
+              </a:schemeClr>
+            </a:gs>
+            <a:gs pos="40000">
+              <a:schemeClr val="phClr">
+                <a:tint val="45000"/>
+                <a:shade val="99000"/>
+                <a:satMod val="350000"/>
+              </a:schemeClr>
+            </a:gs>
+            <a:gs pos="100000">
+              <a:schemeClr val="phClr">
+                <a:shade val="20000"/>
+                <a:satMod val="255000"/>
+              </a:schemeClr>
+            </a:gs>
+          </a:gsLst>
+          <a:path path="circle">
+            <a:fillToRect l="50000" t="-80000" r="50000" b="180000"/>
+          </a:path>
+        </a:gradFill>
+        <a:gradFill rotWithShape="1">
+          <a:gsLst>
+            <a:gs pos="0">
+              <a:schemeClr val="phClr">
+                <a:tint val="80000"/>
+                <a:satMod val="300000"/>
+              </a:schemeClr>
+            </a:gs>
+            <a:gs pos="100000">
+              <a:schemeClr val="phClr">
+                <a:shade val="30000"/>
+                <a:satMod val="200000"/>
+              </a:schemeClr>
+            </a:gs>
+          </a:gsLst>
+          <a:path path="circle">
+            <a:fillToRect l="50000" t="50000" r="50000" b="50000"/>
+          </a:path>
+        </a:gradFill>
+      </a:bgFillStyleLst>
+    </a:fmtScheme>
+  </a:themeElements>
+</a:theme>
+</file>
+
+<file path=ppt/theme/theme3.xml><?xml version="1.0" encoding="utf-8"?>
 <a:theme xmlns:a="http://schemas.openxmlformats.org/drawingml/2006/main" xmlns:r="http://schemas.openxmlformats.org/officeDocument/2006/relationships">
   <a:themeElements>
     <a:clrScheme name="Default">
@@ -22907,283 +23368,4 @@
     </a:fmtScheme>
   </a:themeElements>
 </a:theme>
-</file>
-
-<file path=ppt/theme/theme3.xml><?xml version="1.0" encoding="utf-8"?>
-<a:theme xmlns:a="http://schemas.openxmlformats.org/drawingml/2006/main" xmlns:r="http://schemas.openxmlformats.org/officeDocument/2006/relationships" name="Spearmint">
-  <a:themeElements>
-    <a:clrScheme name="Spearmint">
-      <a:dk1>
-        <a:srgbClr val="202729"/>
-      </a:dk1>
-      <a:lt1>
-        <a:srgbClr val="FFFFFF"/>
-      </a:lt1>
-      <a:dk2>
-        <a:srgbClr val="4BA173"/>
-      </a:dk2>
-      <a:lt2>
-        <a:srgbClr val="63D297"/>
-      </a:lt2>
-      <a:accent1>
-        <a:srgbClr val="353744"/>
-      </a:accent1>
-      <a:accent2>
-        <a:srgbClr val="424242"/>
-      </a:accent2>
-      <a:accent3>
-        <a:srgbClr val="616161"/>
-      </a:accent3>
-      <a:accent4>
-        <a:srgbClr val="999999"/>
-      </a:accent4>
-      <a:accent5>
-        <a:srgbClr val="FF5252"/>
-      </a:accent5>
-      <a:accent6>
-        <a:srgbClr val="FFF176"/>
-      </a:accent6>
-      <a:hlink>
-        <a:srgbClr val="FF5252"/>
-      </a:hlink>
-      <a:folHlink>
-        <a:srgbClr val="FF5252"/>
-      </a:folHlink>
-    </a:clrScheme>
-    <a:fontScheme name="Office">
-      <a:majorFont>
-        <a:latin typeface="Arial"/>
-        <a:ea typeface=""/>
-        <a:cs typeface=""/>
-        <a:font script="Jpan" typeface="ＭＳ Ｐゴシック"/>
-        <a:font script="Hang" typeface="맑은 고딕"/>
-        <a:font script="Hans" typeface="宋体"/>
-        <a:font script="Hant" typeface="新細明體"/>
-        <a:font script="Arab" typeface="Times New Roman"/>
-        <a:font script="Hebr" typeface="Times New Roman"/>
-        <a:font script="Thai" typeface="Angsana New"/>
-        <a:font script="Ethi" typeface="Nyala"/>
-        <a:font script="Beng" typeface="Vrinda"/>
-        <a:font script="Gujr" typeface="Shruti"/>
-        <a:font script="Khmr" typeface="MoolBoran"/>
-        <a:font script="Knda" typeface="Tunga"/>
-        <a:font script="Guru" typeface="Raavi"/>
-        <a:font script="Cans" typeface="Euphemia"/>
-        <a:font script="Cher" typeface="Plantagenet Cherokee"/>
-        <a:font script="Yiii" typeface="Microsoft Yi Baiti"/>
-        <a:font script="Tibt" typeface="Microsoft Himalaya"/>
-        <a:font script="Thaa" typeface="MV Boli"/>
-        <a:font script="Deva" typeface="Mangal"/>
-        <a:font script="Telu" typeface="Gautami"/>
-        <a:font script="Taml" typeface="Latha"/>
-        <a:font script="Syrc" typeface="Estrangelo Edessa"/>
-        <a:font script="Orya" typeface="Kalinga"/>
-        <a:font script="Mlym" typeface="Kartika"/>
-        <a:font script="Laoo" typeface="DokChampa"/>
-        <a:font script="Sinh" typeface="Iskoola Pota"/>
-        <a:font script="Mong" typeface="Mongolian Baiti"/>
-        <a:font script="Viet" typeface="Times New Roman"/>
-        <a:font script="Uigh" typeface="Microsoft Uighur"/>
-        <a:font script="Geor" typeface="Sylfaen"/>
-      </a:majorFont>
-      <a:minorFont>
-        <a:latin typeface="Arial"/>
-        <a:ea typeface=""/>
-        <a:cs typeface=""/>
-        <a:font script="Jpan" typeface="ＭＳ Ｐゴシック"/>
-        <a:font script="Hang" typeface="맑은 고딕"/>
-        <a:font script="Hans" typeface="宋体"/>
-        <a:font script="Hant" typeface="新細明體"/>
-        <a:font script="Arab" typeface="Arial"/>
-        <a:font script="Hebr" typeface="Arial"/>
-        <a:font script="Thai" typeface="Cordia New"/>
-        <a:font script="Ethi" typeface="Nyala"/>
-        <a:font script="Beng" typeface="Vrinda"/>
-        <a:font script="Gujr" typeface="Shruti"/>
-        <a:font script="Khmr" typeface="DaunPenh"/>
-        <a:font script="Knda" typeface="Tunga"/>
-        <a:font script="Guru" typeface="Raavi"/>
-        <a:font script="Cans" typeface="Euphemia"/>
-        <a:font script="Cher" typeface="Plantagenet Cherokee"/>
-        <a:font script="Yiii" typeface="Microsoft Yi Baiti"/>
-        <a:font script="Tibt" typeface="Microsoft Himalaya"/>
-        <a:font script="Thaa" typeface="MV Boli"/>
-        <a:font script="Deva" typeface="Mangal"/>
-        <a:font script="Telu" typeface="Gautami"/>
-        <a:font script="Taml" typeface="Latha"/>
-        <a:font script="Syrc" typeface="Estrangelo Edessa"/>
-        <a:font script="Orya" typeface="Kalinga"/>
-        <a:font script="Mlym" typeface="Kartika"/>
-        <a:font script="Laoo" typeface="DokChampa"/>
-        <a:font script="Sinh" typeface="Iskoola Pota"/>
-        <a:font script="Mong" typeface="Mongolian Baiti"/>
-        <a:font script="Viet" typeface="Arial"/>
-        <a:font script="Uigh" typeface="Microsoft Uighur"/>
-        <a:font script="Geor" typeface="Sylfaen"/>
-      </a:minorFont>
-    </a:fontScheme>
-    <a:fmtScheme name="Office">
-      <a:fillStyleLst>
-        <a:solidFill>
-          <a:schemeClr val="phClr"/>
-        </a:solidFill>
-        <a:gradFill rotWithShape="1">
-          <a:gsLst>
-            <a:gs pos="0">
-              <a:schemeClr val="phClr">
-                <a:tint val="50000"/>
-                <a:satMod val="300000"/>
-              </a:schemeClr>
-            </a:gs>
-            <a:gs pos="35000">
-              <a:schemeClr val="phClr">
-                <a:tint val="37000"/>
-                <a:satMod val="300000"/>
-              </a:schemeClr>
-            </a:gs>
-            <a:gs pos="100000">
-              <a:schemeClr val="phClr">
-                <a:tint val="15000"/>
-                <a:satMod val="350000"/>
-              </a:schemeClr>
-            </a:gs>
-          </a:gsLst>
-          <a:lin ang="16200000" scaled="1"/>
-        </a:gradFill>
-        <a:gradFill rotWithShape="1">
-          <a:gsLst>
-            <a:gs pos="0">
-              <a:schemeClr val="phClr">
-                <a:tint val="100000"/>
-                <a:shade val="100000"/>
-                <a:satMod val="130000"/>
-              </a:schemeClr>
-            </a:gs>
-            <a:gs pos="100000">
-              <a:schemeClr val="phClr">
-                <a:tint val="50000"/>
-                <a:shade val="100000"/>
-                <a:satMod val="350000"/>
-              </a:schemeClr>
-            </a:gs>
-          </a:gsLst>
-          <a:lin ang="16200000" scaled="0"/>
-        </a:gradFill>
-      </a:fillStyleLst>
-      <a:lnStyleLst>
-        <a:ln w="9525" cap="flat" cmpd="sng" algn="ctr">
-          <a:solidFill>
-            <a:schemeClr val="phClr">
-              <a:shade val="95000"/>
-              <a:satMod val="105000"/>
-            </a:schemeClr>
-          </a:solidFill>
-          <a:prstDash val="solid"/>
-        </a:ln>
-        <a:ln w="25400" cap="flat" cmpd="sng" algn="ctr">
-          <a:solidFill>
-            <a:schemeClr val="phClr"/>
-          </a:solidFill>
-          <a:prstDash val="solid"/>
-        </a:ln>
-        <a:ln w="38100" cap="flat" cmpd="sng" algn="ctr">
-          <a:solidFill>
-            <a:schemeClr val="phClr"/>
-          </a:solidFill>
-          <a:prstDash val="solid"/>
-        </a:ln>
-      </a:lnStyleLst>
-      <a:effectStyleLst>
-        <a:effectStyle>
-          <a:effectLst>
-            <a:outerShdw blurRad="40000" dist="20000" dir="5400000" rotWithShape="0">
-              <a:srgbClr val="000000">
-                <a:alpha val="38000"/>
-              </a:srgbClr>
-            </a:outerShdw>
-          </a:effectLst>
-        </a:effectStyle>
-        <a:effectStyle>
-          <a:effectLst>
-            <a:outerShdw blurRad="40000" dist="23000" dir="5400000" rotWithShape="0">
-              <a:srgbClr val="000000">
-                <a:alpha val="35000"/>
-              </a:srgbClr>
-            </a:outerShdw>
-          </a:effectLst>
-        </a:effectStyle>
-        <a:effectStyle>
-          <a:effectLst>
-            <a:outerShdw blurRad="40000" dist="23000" dir="5400000" rotWithShape="0">
-              <a:srgbClr val="000000">
-                <a:alpha val="35000"/>
-              </a:srgbClr>
-            </a:outerShdw>
-          </a:effectLst>
-          <a:scene3d>
-            <a:camera prst="orthographicFront">
-              <a:rot lat="0" lon="0" rev="0"/>
-            </a:camera>
-            <a:lightRig rig="threePt" dir="t">
-              <a:rot lat="0" lon="0" rev="1200000"/>
-            </a:lightRig>
-          </a:scene3d>
-          <a:sp3d>
-            <a:bevelT w="63500" h="25400"/>
-          </a:sp3d>
-        </a:effectStyle>
-      </a:effectStyleLst>
-      <a:bgFillStyleLst>
-        <a:solidFill>
-          <a:schemeClr val="phClr"/>
-        </a:solidFill>
-        <a:gradFill rotWithShape="1">
-          <a:gsLst>
-            <a:gs pos="0">
-              <a:schemeClr val="phClr">
-                <a:tint val="40000"/>
-                <a:satMod val="350000"/>
-              </a:schemeClr>
-            </a:gs>
-            <a:gs pos="40000">
-              <a:schemeClr val="phClr">
-                <a:tint val="45000"/>
-                <a:shade val="99000"/>
-                <a:satMod val="350000"/>
-              </a:schemeClr>
-            </a:gs>
-            <a:gs pos="100000">
-              <a:schemeClr val="phClr">
-                <a:shade val="20000"/>
-                <a:satMod val="255000"/>
-              </a:schemeClr>
-            </a:gs>
-          </a:gsLst>
-          <a:path path="circle">
-            <a:fillToRect l="50000" t="-80000" r="50000" b="180000"/>
-          </a:path>
-        </a:gradFill>
-        <a:gradFill rotWithShape="1">
-          <a:gsLst>
-            <a:gs pos="0">
-              <a:schemeClr val="phClr">
-                <a:tint val="80000"/>
-                <a:satMod val="300000"/>
-              </a:schemeClr>
-            </a:gs>
-            <a:gs pos="100000">
-              <a:schemeClr val="phClr">
-                <a:shade val="30000"/>
-                <a:satMod val="200000"/>
-              </a:schemeClr>
-            </a:gs>
-          </a:gsLst>
-          <a:path path="circle">
-            <a:fillToRect l="50000" t="50000" r="50000" b="50000"/>
-          </a:path>
-        </a:gradFill>
-      </a:bgFillStyleLst>
-    </a:fmtScheme>
-  </a:themeElements>
-</a:theme>
 </file>
</xml_diff>